<commit_message>
docs: clarify attention report slides shape annotations and labels
</commit_message>
<xml_diff>
--- a/attention融合算子优化报告/attention融合算子优化报告.pptx
+++ b/attention融合算子优化报告/attention融合算子优化报告.pptx
@@ -9689,7 +9689,7 @@
                 <a:ea typeface="Microsoft YaHei"/>
                 <a:cs typeface="Microsoft YaHei"/>
               </a:rPr>
-              <a:t>两张图来自同机同批采集，代码相同，仅 stage 数不同</a:t>
+              <a:t>以 S=4096 为例：两张图来自同机同批采集，代码相同，仅 stage 数不同</a:t>
             </a:r>
           </a:p>
         </p:txBody>
@@ -12196,7 +12196,7 @@
                 <a:ea typeface="Consolas"/>
                 <a:cs typeface="Consolas"/>
               </a:rPr>
-              <a:t>    # 948 是候选延迟估计，不是实测等待时间</a:t>
+              <a:t>    # 按参考实现 ~1.41 ops/cycle 折算：1344 / 1.41 ≈ 948</a:t>
             </a:r>
           </a:p>
           <a:p xmlns:a="http://schemas.openxmlformats.org/drawingml/2006/main">
@@ -12740,7 +12740,7 @@
                 <a:ea typeface="Microsoft YaHei"/>
                 <a:cs typeface="Microsoft YaHei"/>
               </a:rPr>
-              <a:t>948 是候选延迟估计，不是实测等待时延。</a:t>
+              <a:t>S=196：13.3 → 12.1 us；S=1600 / 4096 时延不变。</a:t>
             </a:r>
           </a:p>
         </p:txBody>
@@ -12964,7 +12964,7 @@
                 <a:ea typeface="Microsoft YaHei"/>
                 <a:cs typeface="Microsoft YaHei"/>
               </a:rPr>
-              <a:t>这里保留源文档的三 case 归一化图，并列出原始绝对时延</a:t>
+              <a:t>三 case 时延演进，归一化到原始实现；并列出原始绝对时延</a:t>
             </a:r>
           </a:p>
         </p:txBody>
@@ -23582,7 +23582,7 @@
                 <a:ea typeface="Microsoft YaHei"/>
                 <a:cs typeface="Microsoft YaHei"/>
               </a:rPr>
-              <a:t>①</a:t>
+              <a:t>A</a:t>
             </a:r>
           </a:p>
         </p:txBody>
@@ -23667,7 +23667,7 @@
                 <a:ea typeface="Microsoft YaHei"/>
                 <a:cs typeface="Microsoft YaHei"/>
               </a:rPr>
-              <a:t>②</a:t>
+              <a:t>B</a:t>
             </a:r>
           </a:p>
         </p:txBody>
@@ -23752,7 +23752,7 @@
                 <a:ea typeface="Microsoft YaHei"/>
                 <a:cs typeface="Microsoft YaHei"/>
               </a:rPr>
-              <a:t>③</a:t>
+              <a:t>C</a:t>
             </a:r>
           </a:p>
         </p:txBody>
@@ -23867,7 +23867,7 @@
                 <a:ea typeface="Microsoft YaHei"/>
                 <a:cs typeface="Microsoft YaHei"/>
               </a:rPr>
-              <a:t>编号与上方流程节点一一对应：</a:t>
+              <a:t>标记 A / B / C 与上方流程节点一一对应：</a:t>
             </a:r>
           </a:p>
         </p:txBody>
@@ -23954,7 +23954,7 @@
                 <a:ea typeface="Microsoft YaHei"/>
                 <a:cs typeface="Microsoft YaHei"/>
               </a:rPr>
-              <a:t>① bias 分支索引（score UB）</a:t>
+              <a:t>A bias 分支索引（score UB）</a:t>
             </a:r>
           </a:p>
         </p:txBody>
@@ -24096,7 +24096,7 @@
                 <a:ea typeface="Microsoft YaHei"/>
                 <a:cs typeface="Microsoft YaHei"/>
               </a:rPr>
-              <a:t>② P 布局中转（P NZ UB）</a:t>
+              <a:t>B P 布局中转（P NZ UB）</a:t>
             </a:r>
           </a:p>
         </p:txBody>
@@ -24238,7 +24238,7 @@
                 <a:ea typeface="Microsoft YaHei"/>
                 <a:cs typeface="Microsoft YaHei"/>
               </a:rPr>
-              <a:t>③ C / V 交接（QK → PV）</a:t>
+              <a:t>C C / V 交接（QK → PV）</a:t>
             </a:r>
           </a:p>
         </p:txBody>

</xml_diff>